<commit_message>
Engage HWC Construction/Ops from design kickoff
Constructability and field-operations input now starts at design,
not estimate or mobilization: updated the critical-relationship
callout, organization roles, and process flow Design step across
markdown, HTML, PDF, and the PowerPoint deck.

Co-Authored-By: Claude Fable 5 <noreply@anthropic.com>
Claude-Session: https://claude.ai/code/session_01VrQFqy4MVniz1ZR4Ywwp9h
</commit_message>
<xml_diff>
--- a/processes/USC-CVR-Integrated-Capital-Delivery-Process.pptx
+++ b/processes/USC-CVR-Integrated-Capital-Delivery-Process.pptx
@@ -8692,7 +8692,35 @@
                 <a:ea typeface="Arial" pitchFamily="34" charset="-122"/>
                 <a:cs typeface="Arial" pitchFamily="34" charset="-120"/>
               </a:rPr>
-              <a:t>the CVR PM (capital delivery: cost, schedule, procurement, reporting) and the HWC Construction PM (field execution: crews, production, constructability) meet weekly, share one schedule and one cost picture, and jointly own the outcome.</a:t>
+              <a:t>the CVR PM (capital delivery) and the HWC Construction/Ops PM (constructability and field operations) — </a:t>
+            </a:r>
+            <a:pPr indent="0" marL="0">
+              <a:buNone/>
+            </a:pPr>
+            <a:r>
+              <a:rPr lang="en-US" sz="1450" b="1" dirty="0">
+                <a:solidFill>
+                  <a:srgbClr val="231F20"/>
+                </a:solidFill>
+                <a:latin typeface="Arial" pitchFamily="34" charset="0"/>
+                <a:ea typeface="Arial" pitchFamily="34" charset="-122"/>
+                <a:cs typeface="Arial" pitchFamily="34" charset="-120"/>
+              </a:rPr>
+              <a:t>engaged from design kickoff, not mobilization</a:t>
+            </a:r>
+            <a:pPr indent="0" marL="0">
+              <a:buNone/>
+            </a:pPr>
+            <a:r>
+              <a:rPr lang="en-US" sz="1450" dirty="0">
+                <a:solidFill>
+                  <a:srgbClr val="231F20"/>
+                </a:solidFill>
+                <a:latin typeface="Arial" pitchFamily="34" charset="0"/>
+                <a:ea typeface="Arial" pitchFamily="34" charset="-122"/>
+                <a:cs typeface="Arial" pitchFamily="34" charset="-120"/>
+              </a:rPr>
+              <a:t> — meet weekly, share one schedule and one cost picture, and jointly own the outcome.</a:t>
             </a:r>
             <a:endParaRPr lang="en-US" sz="1450" dirty="0"/>
           </a:p>
@@ -9673,7 +9701,7 @@
                 <a:ea typeface="Arial" pitchFamily="34" charset="-122"/>
                 <a:cs typeface="Arial" pitchFamily="34" charset="-120"/>
               </a:rPr>
-              <a:t>CVR Engineering (EOR)</a:t>
+              <a:t>CVR Engineering (EOR) + HWC Constr/Ops</a:t>
             </a:r>
             <a:endParaRPr lang="en-US" sz="1250" dirty="0"/>
           </a:p>
@@ -9712,7 +9740,7 @@
                 <a:ea typeface="Arial" pitchFamily="34" charset="-122"/>
                 <a:cs typeface="Arial" pitchFamily="34" charset="-120"/>
               </a:rPr>
-              <a:t>Quantity takeoffs and technical specifications</a:t>
+              <a:t>Takeoffs and specs — constructability and field-ops input from day one</a:t>
             </a:r>
             <a:endParaRPr lang="en-US" sz="1100" dirty="0"/>
           </a:p>

</xml_diff>

<commit_message>
Reframe estimates gap as ownership issue, not absence
'Estimates built blind' overstated the problem — engineering does
contribute to estimates today. Reworded across deck slide 2 and
the executive summaries: estimates draw on engineering input but
lack an engineering owner to drive them.

Co-Authored-By: Claude Fable 5 <noreply@anthropic.com>
Claude-Session: https://claude.ai/code/session_01VrQFqy4MVniz1ZR4Ywwp9h
</commit_message>
<xml_diff>
--- a/processes/USC-CVR-Integrated-Capital-Delivery-Process.pptx
+++ b/processes/USC-CVR-Integrated-Capital-Delivery-Process.pptx
@@ -5973,7 +5973,7 @@
                 <a:ea typeface="Arial" pitchFamily="34" charset="-122"/>
                 <a:cs typeface="Arial" pitchFamily="34" charset="-120"/>
               </a:rPr>
-              <a:t>Estimates built blind</a:t>
+              <a:t>Estimates lack an engineering driver</a:t>
             </a:r>
             <a:endParaRPr lang="en-US" sz="1600" dirty="0"/>
           </a:p>
@@ -6012,7 +6012,7 @@
                 <a:ea typeface="Arial" pitchFamily="34" charset="-122"/>
                 <a:cs typeface="Arial" pitchFamily="34" charset="-120"/>
               </a:rPr>
-              <a:t>Estimates assembled without design quantities or field production input</a:t>
+              <a:t>Engineering contributes to estimates today — but no one in engineering owns and drives them, so the technical basis isn’t consistently led</a:t>
             </a:r>
             <a:endParaRPr lang="en-US" sz="1350" dirty="0"/>
           </a:p>

</xml_diff>